<commit_message>
sync pptx with live webapp data
- Update all provider scores to match webapp (Queen 99, Mike 96,
  Les lunettes 84, Penthievre 78, Runner 74, Kylian 54, Roudoudou 40, Voodoo 15)
- Fix provider statuses (3 needs_review, 5 auto_held, 4 auto_approved)
- Update detection rule scores (+20 spike, max +25 cobilling, +15 repeated, +15 round)
- Round number rule now says whole euros not multiples of 50
- Update summary/recommendations table with correct scores and actions

Co-Authored-By: Claude Sonnet 4.6 <noreply@anthropic.com>
</commit_message>
<xml_diff>
--- a/fraud_ops_presentation_updated.pptx
+++ b/fraud_ops_presentation_updated.pptx
@@ -4098,7 +4098,7 @@
                   <a:srgbClr val="1A2440"/>
                 </a:solidFill>
               </a:rPr>
-              <a:t>+30 points per spiked month</a:t>
+              <a:t>+20 points per spiked month</a:t>
             </a:r>
           </a:p>
         </p:txBody>
@@ -4474,7 +4474,7 @@
                   <a:srgbClr val="1A2440"/>
                 </a:solidFill>
               </a:rPr>
-              <a:t>25–50 pts  (scales with rate)</a:t>
+              <a:t>12–25 pts  (scales with rate)</a:t>
             </a:r>
           </a:p>
         </p:txBody>
@@ -4850,7 +4850,7 @@
                   <a:srgbClr val="1A2440"/>
                 </a:solidFill>
               </a:rPr>
-              <a:t>+20 points per pattern</a:t>
+              <a:t>+15 points per pattern</a:t>
             </a:r>
           </a:p>
         </p:txBody>
@@ -5038,7 +5038,7 @@
                   <a:srgbClr val="CCCCCC"/>
                 </a:solidFill>
               </a:rPr>
-              <a:t>Flag providers where ≥ 70% of claims in a category are round numbers (whole euros, multiples of 50). Real optical purchases have irregular amounts like 349.91€.</a:t>
+              <a:t>Flag providers where ≥ 70% of claims in a category are whole euro amounts (no cents). Real optical purchases have irregular amounts like 349.91€.</a:t>
             </a:r>
           </a:p>
         </p:txBody>
@@ -5149,7 +5149,7 @@
                   <a:srgbClr val="FFFFFF"/>
                 </a:solidFill>
               </a:rPr>
-              <a:t>≥ 70% of claims are multiples of 50</a:t>
+              <a:t>≥ 70% of claims are whole euros</a:t>
             </a:r>
           </a:p>
         </p:txBody>
@@ -5226,7 +5226,7 @@
                   <a:srgbClr val="1A2440"/>
                 </a:solidFill>
               </a:rPr>
-              <a:t>+25 points per category</a:t>
+              <a:t>+15 points per category</a:t>
             </a:r>
           </a:p>
         </p:txBody>
@@ -13342,7 +13342,7 @@
                   <a:srgbClr val="1A2440"/>
                 </a:solidFill>
               </a:rPr>
-              <a:t>Les lunettes à Soso</a:t>
+              <a:t>Queen optics</a:t>
             </a:r>
           </a:p>
         </p:txBody>
@@ -13376,7 +13376,7 @@
                   <a:srgbClr val="D62839"/>
                 </a:solidFill>
               </a:rPr>
-              <a:t>100</a:t>
+              <a:t>99</a:t>
             </a:r>
           </a:p>
         </p:txBody>
@@ -13444,7 +13444,7 @@
                   <a:srgbClr val="444444"/>
                 </a:solidFill>
               </a:rPr>
-              <a:t>Co-billing + spike + repeated + rounds</a:t>
+              <a:t>Co-billing + spike + rounds</a:t>
             </a:r>
           </a:p>
         </p:txBody>
@@ -13478,7 +13478,7 @@
                   <a:srgbClr val="444444"/>
                 </a:solidFill>
               </a:rPr>
-              <a:t>Immediate audit — 4 independent fraud signals</a:t>
+              <a:t>Full audit + suspend payments</a:t>
             </a:r>
           </a:p>
         </p:txBody>
@@ -13555,7 +13555,7 @@
                   <a:srgbClr val="1A2440"/>
                 </a:solidFill>
               </a:rPr>
-              <a:t>Penthievre alambics</a:t>
+              <a:t>Mike lunettes</a:t>
             </a:r>
           </a:p>
         </p:txBody>
@@ -13589,7 +13589,7 @@
                   <a:srgbClr val="D62839"/>
                 </a:solidFill>
               </a:rPr>
-              <a:t>100</a:t>
+              <a:t>96</a:t>
             </a:r>
           </a:p>
         </p:txBody>
@@ -13768,7 +13768,7 @@
                   <a:srgbClr val="1A2440"/>
                 </a:solidFill>
               </a:rPr>
-              <a:t>Queen optics</a:t>
+              <a:t>Les lunettes à Soso</a:t>
             </a:r>
           </a:p>
         </p:txBody>
@@ -13802,7 +13802,7 @@
                   <a:srgbClr val="D62839"/>
                 </a:solidFill>
               </a:rPr>
-              <a:t>100</a:t>
+              <a:t>84</a:t>
             </a:r>
           </a:p>
         </p:txBody>
@@ -13870,7 +13870,7 @@
                   <a:srgbClr val="444444"/>
                 </a:solidFill>
               </a:rPr>
-              <a:t>Co-billing + spike + rounds</a:t>
+              <a:t>Co-billing + spike + repeated + rounds</a:t>
             </a:r>
           </a:p>
         </p:txBody>
@@ -13904,7 +13904,7 @@
                   <a:srgbClr val="444444"/>
                 </a:solidFill>
               </a:rPr>
-              <a:t>Full audit + suspend payments</a:t>
+              <a:t>Immediate audit — 4 independent fraud signals</a:t>
             </a:r>
           </a:p>
         </p:txBody>
@@ -13981,7 +13981,7 @@
                   <a:srgbClr val="1A2440"/>
                 </a:solidFill>
               </a:rPr>
-              <a:t>Mike lunettes</a:t>
+              <a:t>Penthievre alambics</a:t>
             </a:r>
           </a:p>
         </p:txBody>
@@ -14015,7 +14015,7 @@
                   <a:srgbClr val="D62839"/>
                 </a:solidFill>
               </a:rPr>
-              <a:t>100</a:t>
+              <a:t>78</a:t>
             </a:r>
           </a:p>
         </p:txBody>
@@ -14228,7 +14228,7 @@
                   <a:srgbClr val="D62839"/>
                 </a:solidFill>
               </a:rPr>
-              <a:t>100</a:t>
+              <a:t>74</a:t>
             </a:r>
           </a:p>
         </p:txBody>
@@ -14350,7 +14350,7 @@
             <a:avLst/>
           </a:prstGeom>
           <a:solidFill>
-            <a:srgbClr val="FFEBEB"/>
+            <a:srgbClr val="FFF3E6"/>
           </a:solidFill>
           <a:ln>
             <a:noFill/>
@@ -14402,7 +14402,7 @@
           <a:p>
             <a:pPr algn="l"/>
             <a:r>
-              <a:rPr sz="1100" b="1" i="0">
+              <a:rPr sz="1100" b="0" i="0">
                 <a:solidFill>
                   <a:srgbClr val="1A2440"/>
                 </a:solidFill>
@@ -14438,10 +14438,10 @@
             <a:r>
               <a:rPr sz="1200" b="1" i="0">
                 <a:solidFill>
-                  <a:srgbClr val="D62839"/>
-                </a:solidFill>
-              </a:rPr>
-              <a:t>93</a:t>
+                  <a:srgbClr val="E07B39"/>
+                </a:solidFill>
+              </a:rPr>
+              <a:t>54</a:t>
             </a:r>
           </a:p>
         </p:txBody>
@@ -14472,10 +14472,10 @@
             <a:r>
               <a:rPr sz="1000" b="1" i="0">
                 <a:solidFill>
-                  <a:srgbClr val="D62839"/>
-                </a:solidFill>
-              </a:rPr>
-              <a:t>Payments held</a:t>
+                  <a:srgbClr val="E07B39"/>
+                </a:solidFill>
+              </a:rPr>
+              <a:t>Under review</a:t>
             </a:r>
           </a:p>
         </p:txBody>
@@ -14543,7 +14543,7 @@
                   <a:srgbClr val="444444"/>
                 </a:solidFill>
               </a:rPr>
-              <a:t>Payments held — multiple signals</a:t>
+              <a:t>Manual review — multiple signals, below hold threshold</a:t>
             </a:r>
           </a:p>
         </p:txBody>
@@ -14563,7 +14563,7 @@
             <a:avLst/>
           </a:prstGeom>
           <a:solidFill>
-            <a:srgbClr val="FFEBEB"/>
+            <a:srgbClr val="FFF3E6"/>
           </a:solidFill>
           <a:ln>
             <a:noFill/>
@@ -14615,7 +14615,7 @@
           <a:p>
             <a:pPr algn="l"/>
             <a:r>
-              <a:rPr sz="1100" b="1" i="0">
+              <a:rPr sz="1100" b="0" i="0">
                 <a:solidFill>
                   <a:srgbClr val="1A2440"/>
                 </a:solidFill>
@@ -14651,10 +14651,10 @@
             <a:r>
               <a:rPr sz="1200" b="1" i="0">
                 <a:solidFill>
-                  <a:srgbClr val="D62839"/>
-                </a:solidFill>
-              </a:rPr>
-              <a:t>75</a:t>
+                  <a:srgbClr val="E07B39"/>
+                </a:solidFill>
+              </a:rPr>
+              <a:t>40</a:t>
             </a:r>
           </a:p>
         </p:txBody>
@@ -14685,10 +14685,10 @@
             <a:r>
               <a:rPr sz="1000" b="1" i="0">
                 <a:solidFill>
-                  <a:srgbClr val="D62839"/>
-                </a:solidFill>
-              </a:rPr>
-              <a:t>Payments held</a:t>
+                  <a:srgbClr val="E07B39"/>
+                </a:solidFill>
+              </a:rPr>
+              <a:t>Under review</a:t>
             </a:r>
           </a:p>
         </p:txBody>
@@ -14756,7 +14756,7 @@
                   <a:srgbClr val="444444"/>
                 </a:solidFill>
               </a:rPr>
-              <a:t>Payments held — systematic round numbers</a:t>
+              <a:t>Manual review — systematic round numbers</a:t>
             </a:r>
           </a:p>
         </p:txBody>
@@ -14769,7 +14769,220 @@
         </p:nvSpPr>
         <p:spPr>
           <a:xfrm>
-            <a:off x="274320" y="4617720"/>
+            <a:off x="274320" y="4544568"/>
+            <a:ext cx="11640312" cy="384048"/>
+          </a:xfrm>
+          <a:prstGeom prst="rect">
+            <a:avLst/>
+          </a:prstGeom>
+          <a:solidFill>
+            <a:srgbClr val="FFF3E6"/>
+          </a:solidFill>
+          <a:ln>
+            <a:noFill/>
+          </a:ln>
+        </p:spPr>
+        <p:style>
+          <a:lnRef idx="1">
+            <a:schemeClr val="accent1"/>
+          </a:lnRef>
+          <a:fillRef idx="3">
+            <a:schemeClr val="accent1"/>
+          </a:fillRef>
+          <a:effectRef idx="2">
+            <a:schemeClr val="accent1"/>
+          </a:effectRef>
+          <a:fontRef idx="minor">
+            <a:schemeClr val="lt1"/>
+          </a:fontRef>
+        </p:style>
+        <p:txBody>
+          <a:bodyPr rtlCol="0" anchor="ctr"/>
+          <a:lstStyle/>
+          <a:p>
+            <a:pPr algn="ctr"/>
+          </a:p>
+        </p:txBody>
+      </p:sp>
+      <p:sp>
+        <p:nvSpPr>
+          <p:cNvPr id="59" name="TextBox 58"/>
+          <p:cNvSpPr txBox="1"/>
+          <p:nvPr/>
+        </p:nvSpPr>
+        <p:spPr>
+          <a:xfrm>
+            <a:off x="365760" y="4599431"/>
+            <a:ext cx="2834640" cy="274320"/>
+          </a:xfrm>
+          <a:prstGeom prst="rect">
+            <a:avLst/>
+          </a:prstGeom>
+          <a:noFill/>
+        </p:spPr>
+        <p:txBody>
+          <a:bodyPr wrap="square">
+            <a:spAutoFit/>
+          </a:bodyPr>
+          <a:lstStyle/>
+          <a:p>
+            <a:pPr algn="l"/>
+            <a:r>
+              <a:rPr sz="1100" b="0" i="0">
+                <a:solidFill>
+                  <a:srgbClr val="1A2440"/>
+                </a:solidFill>
+              </a:rPr>
+              <a:t>Voodoo</a:t>
+            </a:r>
+          </a:p>
+        </p:txBody>
+      </p:sp>
+      <p:sp>
+        <p:nvSpPr>
+          <p:cNvPr id="60" name="TextBox 59"/>
+          <p:cNvSpPr txBox="1"/>
+          <p:nvPr/>
+        </p:nvSpPr>
+        <p:spPr>
+          <a:xfrm>
+            <a:off x="3291840" y="4599431"/>
+            <a:ext cx="1371600" cy="274320"/>
+          </a:xfrm>
+          <a:prstGeom prst="rect">
+            <a:avLst/>
+          </a:prstGeom>
+          <a:noFill/>
+        </p:spPr>
+        <p:txBody>
+          <a:bodyPr wrap="square">
+            <a:spAutoFit/>
+          </a:bodyPr>
+          <a:lstStyle/>
+          <a:p>
+            <a:pPr algn="l"/>
+            <a:r>
+              <a:rPr sz="1200" b="1" i="0">
+                <a:solidFill>
+                  <a:srgbClr val="E07B39"/>
+                </a:solidFill>
+              </a:rPr>
+              <a:t>15</a:t>
+            </a:r>
+          </a:p>
+        </p:txBody>
+      </p:sp>
+      <p:sp>
+        <p:nvSpPr>
+          <p:cNvPr id="61" name="TextBox 60"/>
+          <p:cNvSpPr txBox="1"/>
+          <p:nvPr/>
+        </p:nvSpPr>
+        <p:spPr>
+          <a:xfrm>
+            <a:off x="4754879" y="4599431"/>
+            <a:ext cx="1600200" cy="274320"/>
+          </a:xfrm>
+          <a:prstGeom prst="rect">
+            <a:avLst/>
+          </a:prstGeom>
+          <a:noFill/>
+        </p:spPr>
+        <p:txBody>
+          <a:bodyPr wrap="square">
+            <a:spAutoFit/>
+          </a:bodyPr>
+          <a:lstStyle/>
+          <a:p>
+            <a:pPr algn="l"/>
+            <a:r>
+              <a:rPr sz="1000" b="1" i="0">
+                <a:solidFill>
+                  <a:srgbClr val="E07B39"/>
+                </a:solidFill>
+              </a:rPr>
+              <a:t>Under review</a:t>
+            </a:r>
+          </a:p>
+        </p:txBody>
+      </p:sp>
+      <p:sp>
+        <p:nvSpPr>
+          <p:cNvPr id="62" name="TextBox 61"/>
+          <p:cNvSpPr txBox="1"/>
+          <p:nvPr/>
+        </p:nvSpPr>
+        <p:spPr>
+          <a:xfrm>
+            <a:off x="6446520" y="4599431"/>
+            <a:ext cx="1874519" cy="274320"/>
+          </a:xfrm>
+          <a:prstGeom prst="rect">
+            <a:avLst/>
+          </a:prstGeom>
+          <a:noFill/>
+        </p:spPr>
+        <p:txBody>
+          <a:bodyPr wrap="square">
+            <a:spAutoFit/>
+          </a:bodyPr>
+          <a:lstStyle/>
+          <a:p>
+            <a:pPr algn="l"/>
+            <a:r>
+              <a:rPr sz="1000" b="0" i="0">
+                <a:solidFill>
+                  <a:srgbClr val="444444"/>
+                </a:solidFill>
+              </a:rPr>
+              <a:t>Round number billing</a:t>
+            </a:r>
+          </a:p>
+        </p:txBody>
+      </p:sp>
+      <p:sp>
+        <p:nvSpPr>
+          <p:cNvPr id="63" name="TextBox 62"/>
+          <p:cNvSpPr txBox="1"/>
+          <p:nvPr/>
+        </p:nvSpPr>
+        <p:spPr>
+          <a:xfrm>
+            <a:off x="8412480" y="4599431"/>
+            <a:ext cx="3474720" cy="274320"/>
+          </a:xfrm>
+          <a:prstGeom prst="rect">
+            <a:avLst/>
+          </a:prstGeom>
+          <a:noFill/>
+        </p:spPr>
+        <p:txBody>
+          <a:bodyPr wrap="square">
+            <a:spAutoFit/>
+          </a:bodyPr>
+          <a:lstStyle/>
+          <a:p>
+            <a:pPr algn="l"/>
+            <a:r>
+              <a:rPr sz="1000" b="0" i="0">
+                <a:solidFill>
+                  <a:srgbClr val="444444"/>
+                </a:solidFill>
+              </a:rPr>
+              <a:t>Monitor — low score but pattern present</a:t>
+            </a:r>
+          </a:p>
+        </p:txBody>
+      </p:sp>
+      <p:sp>
+        <p:nvSpPr>
+          <p:cNvPr id="64" name="Rectangle 63"/>
+          <p:cNvSpPr/>
+          <p:nvPr/>
+        </p:nvSpPr>
+        <p:spPr>
+          <a:xfrm>
+            <a:off x="274320" y="5010912"/>
             <a:ext cx="11640312" cy="1536192"/>
           </a:xfrm>
           <a:prstGeom prst="rect">
@@ -14806,13 +15019,13 @@
       </p:sp>
       <p:sp>
         <p:nvSpPr>
-          <p:cNvPr id="59" name="Rectangle 58"/>
+          <p:cNvPr id="65" name="Rectangle 64"/>
           <p:cNvSpPr/>
           <p:nvPr/>
         </p:nvSpPr>
         <p:spPr>
           <a:xfrm>
-            <a:off x="274320" y="4617720"/>
+            <a:off x="274320" y="5010912"/>
             <a:ext cx="109728" cy="1536192"/>
           </a:xfrm>
           <a:prstGeom prst="rect">
@@ -14849,13 +15062,13 @@
       </p:sp>
       <p:sp>
         <p:nvSpPr>
-          <p:cNvPr id="60" name="TextBox 59"/>
-          <p:cNvSpPr txBox="1"/>
-          <p:nvPr/>
-        </p:nvSpPr>
-        <p:spPr>
-          <a:xfrm>
-            <a:off x="502920" y="4690872"/>
+          <p:cNvPr id="66" name="TextBox 65"/>
+          <p:cNvSpPr txBox="1"/>
+          <p:nvPr/>
+        </p:nvSpPr>
+        <p:spPr>
+          <a:xfrm>
+            <a:off x="502920" y="5084064"/>
             <a:ext cx="5029200" cy="320040"/>
           </a:xfrm>
           <a:prstGeom prst="rect">
@@ -14883,13 +15096,13 @@
       </p:sp>
       <p:sp>
         <p:nvSpPr>
-          <p:cNvPr id="61" name="TextBox 60"/>
-          <p:cNvSpPr txBox="1"/>
-          <p:nvPr/>
-        </p:nvSpPr>
-        <p:spPr>
-          <a:xfrm>
-            <a:off x="502920" y="5056631"/>
+          <p:cNvPr id="67" name="TextBox 66"/>
+          <p:cNvSpPr txBox="1"/>
+          <p:nvPr/>
+        </p:nvSpPr>
+        <p:spPr>
+          <a:xfrm>
+            <a:off x="502920" y="5449823"/>
             <a:ext cx="11155680" cy="256032"/>
           </a:xfrm>
           <a:prstGeom prst="rect">
@@ -14917,13 +15130,13 @@
       </p:sp>
       <p:sp>
         <p:nvSpPr>
-          <p:cNvPr id="62" name="TextBox 61"/>
-          <p:cNvSpPr txBox="1"/>
-          <p:nvPr/>
-        </p:nvSpPr>
-        <p:spPr>
-          <a:xfrm>
-            <a:off x="502920" y="5330951"/>
+          <p:cNvPr id="68" name="TextBox 67"/>
+          <p:cNvSpPr txBox="1"/>
+          <p:nvPr/>
+        </p:nvSpPr>
+        <p:spPr>
+          <a:xfrm>
+            <a:off x="502920" y="5724143"/>
             <a:ext cx="11155680" cy="256032"/>
           </a:xfrm>
           <a:prstGeom prst="rect">
@@ -14951,13 +15164,13 @@
       </p:sp>
       <p:sp>
         <p:nvSpPr>
-          <p:cNvPr id="63" name="TextBox 62"/>
-          <p:cNvSpPr txBox="1"/>
-          <p:nvPr/>
-        </p:nvSpPr>
-        <p:spPr>
-          <a:xfrm>
-            <a:off x="502920" y="5605271"/>
+          <p:cNvPr id="69" name="TextBox 68"/>
+          <p:cNvSpPr txBox="1"/>
+          <p:nvPr/>
+        </p:nvSpPr>
+        <p:spPr>
+          <a:xfrm>
+            <a:off x="502920" y="5998463"/>
             <a:ext cx="11155680" cy="256032"/>
           </a:xfrm>
           <a:prstGeom prst="rect">
@@ -14985,13 +15198,13 @@
       </p:sp>
       <p:sp>
         <p:nvSpPr>
-          <p:cNvPr id="64" name="TextBox 63"/>
-          <p:cNvSpPr txBox="1"/>
-          <p:nvPr/>
-        </p:nvSpPr>
-        <p:spPr>
-          <a:xfrm>
-            <a:off x="502920" y="5879592"/>
+          <p:cNvPr id="70" name="TextBox 69"/>
+          <p:cNvSpPr txBox="1"/>
+          <p:nvPr/>
+        </p:nvSpPr>
+        <p:spPr>
+          <a:xfrm>
+            <a:off x="502920" y="6272783"/>
             <a:ext cx="11155680" cy="256032"/>
           </a:xfrm>
           <a:prstGeom prst="rect">
@@ -17496,7 +17709,7 @@
                   <a:srgbClr val="FFFFFF"/>
                 </a:solidFill>
               </a:rPr>
-              <a:t>7 out of 12 providers showed at least one red flag · 4 distinct fraud patterns identified</a:t>
+              <a:t>8 out of 12 providers showed at least one red flag · 4 distinct fraud patterns identified</a:t>
             </a:r>
           </a:p>
         </p:txBody>
@@ -18078,7 +18291,7 @@
                   <a:srgbClr val="444444"/>
                 </a:solidFill>
               </a:rPr>
-              <a:t>Les lunettes à Soso</a:t>
+              <a:t>Queen optics</a:t>
             </a:r>
           </a:p>
         </p:txBody>
@@ -18112,7 +18325,7 @@
                   <a:srgbClr val="D62839"/>
                 </a:solidFill>
               </a:rPr>
-              <a:t>100</a:t>
+              <a:t>99</a:t>
             </a:r>
           </a:p>
         </p:txBody>
@@ -18180,7 +18393,7 @@
                   <a:srgbClr val="444444"/>
                 </a:solidFill>
               </a:rPr>
-              <a:t>Co-billing + spike + repeated + round numbers</a:t>
+              <a:t>Co-billing + billing spike + round numbers</a:t>
             </a:r>
           </a:p>
         </p:txBody>
@@ -18257,7 +18470,7 @@
                   <a:srgbClr val="444444"/>
                 </a:solidFill>
               </a:rPr>
-              <a:t>Penthievre alambics</a:t>
+              <a:t>Mike lunettes</a:t>
             </a:r>
           </a:p>
         </p:txBody>
@@ -18291,7 +18504,7 @@
                   <a:srgbClr val="D62839"/>
                 </a:solidFill>
               </a:rPr>
-              <a:t>100</a:t>
+              <a:t>96</a:t>
             </a:r>
           </a:p>
         </p:txBody>
@@ -18436,7 +18649,7 @@
                   <a:srgbClr val="444444"/>
                 </a:solidFill>
               </a:rPr>
-              <a:t>Queen optics</a:t>
+              <a:t>Les lunettes à Soso</a:t>
             </a:r>
           </a:p>
         </p:txBody>
@@ -18470,7 +18683,7 @@
                   <a:srgbClr val="D62839"/>
                 </a:solidFill>
               </a:rPr>
-              <a:t>100</a:t>
+              <a:t>84</a:t>
             </a:r>
           </a:p>
         </p:txBody>
@@ -18538,7 +18751,7 @@
                   <a:srgbClr val="444444"/>
                 </a:solidFill>
               </a:rPr>
-              <a:t>Co-billing + billing spike + round numbers</a:t>
+              <a:t>Co-billing + spike + repeated + round numbers</a:t>
             </a:r>
           </a:p>
         </p:txBody>
@@ -18615,7 +18828,7 @@
                   <a:srgbClr val="444444"/>
                 </a:solidFill>
               </a:rPr>
-              <a:t>Mike lunettes</a:t>
+              <a:t>Penthievre alambics</a:t>
             </a:r>
           </a:p>
         </p:txBody>
@@ -18649,7 +18862,7 @@
                   <a:srgbClr val="D62839"/>
                 </a:solidFill>
               </a:rPr>
-              <a:t>100</a:t>
+              <a:t>78</a:t>
             </a:r>
           </a:p>
         </p:txBody>
@@ -18828,7 +19041,7 @@
                   <a:srgbClr val="D62839"/>
                 </a:solidFill>
               </a:rPr>
-              <a:t>100</a:t>
+              <a:t>74</a:t>
             </a:r>
           </a:p>
         </p:txBody>
@@ -18916,7 +19129,7 @@
             <a:avLst/>
           </a:prstGeom>
           <a:solidFill>
-            <a:srgbClr val="FFEDED"/>
+            <a:srgbClr val="FFF6ED"/>
           </a:solidFill>
           <a:ln>
             <a:noFill/>
@@ -19004,10 +19217,10 @@
             <a:r>
               <a:rPr sz="1200" b="1" i="0">
                 <a:solidFill>
-                  <a:srgbClr val="D62839"/>
-                </a:solidFill>
-              </a:rPr>
-              <a:t>93</a:t>
+                  <a:srgbClr val="E07B39"/>
+                </a:solidFill>
+              </a:rPr>
+              <a:t>54</a:t>
             </a:r>
           </a:p>
         </p:txBody>
@@ -19038,10 +19251,10 @@
             <a:r>
               <a:rPr sz="1000" b="1" i="0">
                 <a:solidFill>
-                  <a:srgbClr val="D62839"/>
-                </a:solidFill>
-              </a:rPr>
-              <a:t>Payments held</a:t>
+                  <a:srgbClr val="E07B39"/>
+                </a:solidFill>
+              </a:rPr>
+              <a:t>Under review</a:t>
             </a:r>
           </a:p>
         </p:txBody>
@@ -19095,7 +19308,7 @@
             <a:avLst/>
           </a:prstGeom>
           <a:solidFill>
-            <a:srgbClr val="FFEDED"/>
+            <a:srgbClr val="FFF6ED"/>
           </a:solidFill>
           <a:ln>
             <a:noFill/>
@@ -19183,10 +19396,10 @@
             <a:r>
               <a:rPr sz="1200" b="1" i="0">
                 <a:solidFill>
-                  <a:srgbClr val="D62839"/>
-                </a:solidFill>
-              </a:rPr>
-              <a:t>75</a:t>
+                  <a:srgbClr val="E07B39"/>
+                </a:solidFill>
+              </a:rPr>
+              <a:t>40</a:t>
             </a:r>
           </a:p>
         </p:txBody>
@@ -19217,10 +19430,10 @@
             <a:r>
               <a:rPr sz="1000" b="1" i="0">
                 <a:solidFill>
-                  <a:srgbClr val="D62839"/>
-                </a:solidFill>
-              </a:rPr>
-              <a:t>Payments held</a:t>
+                  <a:srgbClr val="E07B39"/>
+                </a:solidFill>
+              </a:rPr>
+              <a:t>Under review</a:t>
             </a:r>
           </a:p>
         </p:txBody>
@@ -19268,6 +19481,185 @@
         <p:spPr>
           <a:xfrm>
             <a:off x="274320" y="4306824"/>
+            <a:ext cx="11640312" cy="356616"/>
+          </a:xfrm>
+          <a:prstGeom prst="rect">
+            <a:avLst/>
+          </a:prstGeom>
+          <a:solidFill>
+            <a:srgbClr val="FFF6ED"/>
+          </a:solidFill>
+          <a:ln>
+            <a:noFill/>
+          </a:ln>
+        </p:spPr>
+        <p:style>
+          <a:lnRef idx="1">
+            <a:schemeClr val="accent1"/>
+          </a:lnRef>
+          <a:fillRef idx="3">
+            <a:schemeClr val="accent1"/>
+          </a:fillRef>
+          <a:effectRef idx="2">
+            <a:schemeClr val="accent1"/>
+          </a:effectRef>
+          <a:fontRef idx="minor">
+            <a:schemeClr val="lt1"/>
+          </a:fontRef>
+        </p:style>
+        <p:txBody>
+          <a:bodyPr rtlCol="0" anchor="ctr"/>
+          <a:lstStyle/>
+          <a:p>
+            <a:pPr algn="ctr"/>
+          </a:p>
+        </p:txBody>
+      </p:sp>
+      <p:sp>
+        <p:nvSpPr>
+          <p:cNvPr id="51" name="TextBox 50"/>
+          <p:cNvSpPr txBox="1"/>
+          <p:nvPr/>
+        </p:nvSpPr>
+        <p:spPr>
+          <a:xfrm>
+            <a:off x="365760" y="4352544"/>
+            <a:ext cx="3291840" cy="256032"/>
+          </a:xfrm>
+          <a:prstGeom prst="rect">
+            <a:avLst/>
+          </a:prstGeom>
+          <a:noFill/>
+        </p:spPr>
+        <p:txBody>
+          <a:bodyPr wrap="square">
+            <a:spAutoFit/>
+          </a:bodyPr>
+          <a:lstStyle/>
+          <a:p>
+            <a:pPr algn="l"/>
+            <a:r>
+              <a:rPr sz="1100" b="0" i="0">
+                <a:solidFill>
+                  <a:srgbClr val="444444"/>
+                </a:solidFill>
+              </a:rPr>
+              <a:t>Voodoo</a:t>
+            </a:r>
+          </a:p>
+        </p:txBody>
+      </p:sp>
+      <p:sp>
+        <p:nvSpPr>
+          <p:cNvPr id="52" name="TextBox 51"/>
+          <p:cNvSpPr txBox="1"/>
+          <p:nvPr/>
+        </p:nvSpPr>
+        <p:spPr>
+          <a:xfrm>
+            <a:off x="3794759" y="4352544"/>
+            <a:ext cx="1280160" cy="256032"/>
+          </a:xfrm>
+          <a:prstGeom prst="rect">
+            <a:avLst/>
+          </a:prstGeom>
+          <a:noFill/>
+        </p:spPr>
+        <p:txBody>
+          <a:bodyPr wrap="square">
+            <a:spAutoFit/>
+          </a:bodyPr>
+          <a:lstStyle/>
+          <a:p>
+            <a:pPr algn="l"/>
+            <a:r>
+              <a:rPr sz="1200" b="1" i="0">
+                <a:solidFill>
+                  <a:srgbClr val="E07B39"/>
+                </a:solidFill>
+              </a:rPr>
+              <a:t>15</a:t>
+            </a:r>
+          </a:p>
+        </p:txBody>
+      </p:sp>
+      <p:sp>
+        <p:nvSpPr>
+          <p:cNvPr id="53" name="TextBox 52"/>
+          <p:cNvSpPr txBox="1"/>
+          <p:nvPr/>
+        </p:nvSpPr>
+        <p:spPr>
+          <a:xfrm>
+            <a:off x="5257800" y="4352544"/>
+            <a:ext cx="1600200" cy="256032"/>
+          </a:xfrm>
+          <a:prstGeom prst="rect">
+            <a:avLst/>
+          </a:prstGeom>
+          <a:noFill/>
+        </p:spPr>
+        <p:txBody>
+          <a:bodyPr wrap="square">
+            <a:spAutoFit/>
+          </a:bodyPr>
+          <a:lstStyle/>
+          <a:p>
+            <a:pPr algn="l"/>
+            <a:r>
+              <a:rPr sz="1000" b="1" i="0">
+                <a:solidFill>
+                  <a:srgbClr val="E07B39"/>
+                </a:solidFill>
+              </a:rPr>
+              <a:t>Under review</a:t>
+            </a:r>
+          </a:p>
+        </p:txBody>
+      </p:sp>
+      <p:sp>
+        <p:nvSpPr>
+          <p:cNvPr id="54" name="TextBox 53"/>
+          <p:cNvSpPr txBox="1"/>
+          <p:nvPr/>
+        </p:nvSpPr>
+        <p:spPr>
+          <a:xfrm>
+            <a:off x="6995159" y="4352544"/>
+            <a:ext cx="4937760" cy="256032"/>
+          </a:xfrm>
+          <a:prstGeom prst="rect">
+            <a:avLst/>
+          </a:prstGeom>
+          <a:noFill/>
+        </p:spPr>
+        <p:txBody>
+          <a:bodyPr wrap="square">
+            <a:spAutoFit/>
+          </a:bodyPr>
+          <a:lstStyle/>
+          <a:p>
+            <a:pPr algn="l"/>
+            <a:r>
+              <a:rPr sz="1000" b="0" i="0">
+                <a:solidFill>
+                  <a:srgbClr val="444444"/>
+                </a:solidFill>
+              </a:rPr>
+              <a:t>Round number billing detected</a:t>
+            </a:r>
+          </a:p>
+        </p:txBody>
+      </p:sp>
+      <p:sp>
+        <p:nvSpPr>
+          <p:cNvPr id="55" name="Rectangle 54"/>
+          <p:cNvSpPr/>
+          <p:nvPr/>
+        </p:nvSpPr>
+        <p:spPr>
+          <a:xfrm>
+            <a:off x="274320" y="4663440"/>
             <a:ext cx="11640312" cy="356616"/>
           </a:xfrm>
           <a:prstGeom prst="rect">
@@ -19304,13 +19696,13 @@
       </p:sp>
       <p:sp>
         <p:nvSpPr>
-          <p:cNvPr id="51" name="TextBox 50"/>
-          <p:cNvSpPr txBox="1"/>
-          <p:nvPr/>
-        </p:nvSpPr>
-        <p:spPr>
-          <a:xfrm>
-            <a:off x="365760" y="4352544"/>
+          <p:cNvPr id="56" name="TextBox 55"/>
+          <p:cNvSpPr txBox="1"/>
+          <p:nvPr/>
+        </p:nvSpPr>
+        <p:spPr>
+          <a:xfrm>
+            <a:off x="365760" y="4709159"/>
             <a:ext cx="3291840" cy="256032"/>
           </a:xfrm>
           <a:prstGeom prst="rect">
@@ -19331,20 +19723,20 @@
                   <a:srgbClr val="444444"/>
                 </a:solidFill>
               </a:rPr>
-              <a:t>Voodoo optics</a:t>
-            </a:r>
-          </a:p>
-        </p:txBody>
-      </p:sp>
-      <p:sp>
-        <p:nvSpPr>
-          <p:cNvPr id="52" name="TextBox 51"/>
-          <p:cNvSpPr txBox="1"/>
-          <p:nvPr/>
-        </p:nvSpPr>
-        <p:spPr>
-          <a:xfrm>
-            <a:off x="3794759" y="4352544"/>
+              <a:t>La classe à Dallas</a:t>
+            </a:r>
+          </a:p>
+        </p:txBody>
+      </p:sp>
+      <p:sp>
+        <p:nvSpPr>
+          <p:cNvPr id="57" name="TextBox 56"/>
+          <p:cNvSpPr txBox="1"/>
+          <p:nvPr/>
+        </p:nvSpPr>
+        <p:spPr>
+          <a:xfrm>
+            <a:off x="3794759" y="4709159"/>
             <a:ext cx="1280160" cy="256032"/>
           </a:xfrm>
           <a:prstGeom prst="rect">
@@ -19372,13 +19764,13 @@
       </p:sp>
       <p:sp>
         <p:nvSpPr>
-          <p:cNvPr id="53" name="TextBox 52"/>
-          <p:cNvSpPr txBox="1"/>
-          <p:nvPr/>
-        </p:nvSpPr>
-        <p:spPr>
-          <a:xfrm>
-            <a:off x="5257800" y="4352544"/>
+          <p:cNvPr id="58" name="TextBox 57"/>
+          <p:cNvSpPr txBox="1"/>
+          <p:nvPr/>
+        </p:nvSpPr>
+        <p:spPr>
+          <a:xfrm>
+            <a:off x="5257800" y="4709159"/>
             <a:ext cx="1600200" cy="256032"/>
           </a:xfrm>
           <a:prstGeom prst="rect">
@@ -19406,13 +19798,13 @@
       </p:sp>
       <p:sp>
         <p:nvSpPr>
-          <p:cNvPr id="54" name="TextBox 53"/>
-          <p:cNvSpPr txBox="1"/>
-          <p:nvPr/>
-        </p:nvSpPr>
-        <p:spPr>
-          <a:xfrm>
-            <a:off x="6995159" y="4352544"/>
+          <p:cNvPr id="59" name="TextBox 58"/>
+          <p:cNvSpPr txBox="1"/>
+          <p:nvPr/>
+        </p:nvSpPr>
+        <p:spPr>
+          <a:xfrm>
+            <a:off x="6995159" y="4709159"/>
             <a:ext cx="4937760" cy="256032"/>
           </a:xfrm>
           <a:prstGeom prst="rect">
@@ -19440,13 +19832,13 @@
       </p:sp>
       <p:sp>
         <p:nvSpPr>
-          <p:cNvPr id="55" name="Rectangle 54"/>
+          <p:cNvPr id="60" name="Rectangle 59"/>
           <p:cNvSpPr/>
           <p:nvPr/>
         </p:nvSpPr>
         <p:spPr>
           <a:xfrm>
-            <a:off x="274320" y="4663440"/>
+            <a:off x="274320" y="5020055"/>
             <a:ext cx="11640312" cy="356616"/>
           </a:xfrm>
           <a:prstGeom prst="rect">
@@ -19483,13 +19875,13 @@
       </p:sp>
       <p:sp>
         <p:nvSpPr>
-          <p:cNvPr id="56" name="TextBox 55"/>
-          <p:cNvSpPr txBox="1"/>
-          <p:nvPr/>
-        </p:nvSpPr>
-        <p:spPr>
-          <a:xfrm>
-            <a:off x="365760" y="4709159"/>
+          <p:cNvPr id="61" name="TextBox 60"/>
+          <p:cNvSpPr txBox="1"/>
+          <p:nvPr/>
+        </p:nvSpPr>
+        <p:spPr>
+          <a:xfrm>
+            <a:off x="365760" y="5065775"/>
             <a:ext cx="3291840" cy="256032"/>
           </a:xfrm>
           <a:prstGeom prst="rect">
@@ -19510,20 +19902,20 @@
                   <a:srgbClr val="444444"/>
                 </a:solidFill>
               </a:rPr>
-              <a:t>abc optics</a:t>
-            </a:r>
-          </a:p>
-        </p:txBody>
-      </p:sp>
-      <p:sp>
-        <p:nvSpPr>
-          <p:cNvPr id="57" name="TextBox 56"/>
-          <p:cNvSpPr txBox="1"/>
-          <p:nvPr/>
-        </p:nvSpPr>
-        <p:spPr>
-          <a:xfrm>
-            <a:off x="3794759" y="4709159"/>
+              <a:t>Cool optics</a:t>
+            </a:r>
+          </a:p>
+        </p:txBody>
+      </p:sp>
+      <p:sp>
+        <p:nvSpPr>
+          <p:cNvPr id="62" name="TextBox 61"/>
+          <p:cNvSpPr txBox="1"/>
+          <p:nvPr/>
+        </p:nvSpPr>
+        <p:spPr>
+          <a:xfrm>
+            <a:off x="3794759" y="5065775"/>
             <a:ext cx="1280160" cy="256032"/>
           </a:xfrm>
           <a:prstGeom prst="rect">
@@ -19551,13 +19943,13 @@
       </p:sp>
       <p:sp>
         <p:nvSpPr>
-          <p:cNvPr id="58" name="TextBox 57"/>
-          <p:cNvSpPr txBox="1"/>
-          <p:nvPr/>
-        </p:nvSpPr>
-        <p:spPr>
-          <a:xfrm>
-            <a:off x="5257800" y="4709159"/>
+          <p:cNvPr id="63" name="TextBox 62"/>
+          <p:cNvSpPr txBox="1"/>
+          <p:nvPr/>
+        </p:nvSpPr>
+        <p:spPr>
+          <a:xfrm>
+            <a:off x="5257800" y="5065775"/>
             <a:ext cx="1600200" cy="256032"/>
           </a:xfrm>
           <a:prstGeom prst="rect">
@@ -19585,13 +19977,13 @@
       </p:sp>
       <p:sp>
         <p:nvSpPr>
-          <p:cNvPr id="59" name="TextBox 58"/>
-          <p:cNvSpPr txBox="1"/>
-          <p:nvPr/>
-        </p:nvSpPr>
-        <p:spPr>
-          <a:xfrm>
-            <a:off x="6995159" y="4709159"/>
+          <p:cNvPr id="64" name="TextBox 63"/>
+          <p:cNvSpPr txBox="1"/>
+          <p:nvPr/>
+        </p:nvSpPr>
+        <p:spPr>
+          <a:xfrm>
+            <a:off x="6995159" y="5065775"/>
             <a:ext cx="4937760" cy="256032"/>
           </a:xfrm>
           <a:prstGeom prst="rect">
@@ -19619,13 +20011,13 @@
       </p:sp>
       <p:sp>
         <p:nvSpPr>
-          <p:cNvPr id="60" name="Rectangle 59"/>
+          <p:cNvPr id="65" name="Rectangle 64"/>
           <p:cNvSpPr/>
           <p:nvPr/>
         </p:nvSpPr>
         <p:spPr>
           <a:xfrm>
-            <a:off x="274320" y="5020055"/>
+            <a:off x="274320" y="5376671"/>
             <a:ext cx="11640312" cy="356616"/>
           </a:xfrm>
           <a:prstGeom prst="rect">
@@ -19662,13 +20054,13 @@
       </p:sp>
       <p:sp>
         <p:nvSpPr>
-          <p:cNvPr id="61" name="TextBox 60"/>
-          <p:cNvSpPr txBox="1"/>
-          <p:nvPr/>
-        </p:nvSpPr>
-        <p:spPr>
-          <a:xfrm>
-            <a:off x="365760" y="5065775"/>
+          <p:cNvPr id="66" name="TextBox 65"/>
+          <p:cNvSpPr txBox="1"/>
+          <p:nvPr/>
+        </p:nvSpPr>
+        <p:spPr>
+          <a:xfrm>
+            <a:off x="365760" y="5422391"/>
             <a:ext cx="3291840" cy="256032"/>
           </a:xfrm>
           <a:prstGeom prst="rect">
@@ -19689,20 +20081,20 @@
                   <a:srgbClr val="444444"/>
                 </a:solidFill>
               </a:rPr>
-              <a:t>Cool optics</a:t>
-            </a:r>
-          </a:p>
-        </p:txBody>
-      </p:sp>
-      <p:sp>
-        <p:nvSpPr>
-          <p:cNvPr id="62" name="TextBox 61"/>
-          <p:cNvSpPr txBox="1"/>
-          <p:nvPr/>
-        </p:nvSpPr>
-        <p:spPr>
-          <a:xfrm>
-            <a:off x="3794759" y="5065775"/>
+              <a:t>abc optic</a:t>
+            </a:r>
+          </a:p>
+        </p:txBody>
+      </p:sp>
+      <p:sp>
+        <p:nvSpPr>
+          <p:cNvPr id="67" name="TextBox 66"/>
+          <p:cNvSpPr txBox="1"/>
+          <p:nvPr/>
+        </p:nvSpPr>
+        <p:spPr>
+          <a:xfrm>
+            <a:off x="3794759" y="5422391"/>
             <a:ext cx="1280160" cy="256032"/>
           </a:xfrm>
           <a:prstGeom prst="rect">
@@ -19730,13 +20122,13 @@
       </p:sp>
       <p:sp>
         <p:nvSpPr>
-          <p:cNvPr id="63" name="TextBox 62"/>
-          <p:cNvSpPr txBox="1"/>
-          <p:nvPr/>
-        </p:nvSpPr>
-        <p:spPr>
-          <a:xfrm>
-            <a:off x="5257800" y="5065775"/>
+          <p:cNvPr id="68" name="TextBox 67"/>
+          <p:cNvSpPr txBox="1"/>
+          <p:nvPr/>
+        </p:nvSpPr>
+        <p:spPr>
+          <a:xfrm>
+            <a:off x="5257800" y="5422391"/>
             <a:ext cx="1600200" cy="256032"/>
           </a:xfrm>
           <a:prstGeom prst="rect">
@@ -19764,13 +20156,13 @@
       </p:sp>
       <p:sp>
         <p:nvSpPr>
-          <p:cNvPr id="64" name="TextBox 63"/>
-          <p:cNvSpPr txBox="1"/>
-          <p:nvPr/>
-        </p:nvSpPr>
-        <p:spPr>
-          <a:xfrm>
-            <a:off x="6995159" y="5065775"/>
+          <p:cNvPr id="69" name="TextBox 68"/>
+          <p:cNvSpPr txBox="1"/>
+          <p:nvPr/>
+        </p:nvSpPr>
+        <p:spPr>
+          <a:xfrm>
+            <a:off x="6995159" y="5422391"/>
             <a:ext cx="4937760" cy="256032"/>
           </a:xfrm>
           <a:prstGeom prst="rect">
@@ -19798,13 +20190,13 @@
       </p:sp>
       <p:sp>
         <p:nvSpPr>
-          <p:cNvPr id="65" name="Rectangle 64"/>
+          <p:cNvPr id="70" name="Rectangle 69"/>
           <p:cNvSpPr/>
           <p:nvPr/>
         </p:nvSpPr>
         <p:spPr>
           <a:xfrm>
-            <a:off x="274320" y="5376671"/>
+            <a:off x="274320" y="5733287"/>
             <a:ext cx="11640312" cy="356616"/>
           </a:xfrm>
           <a:prstGeom prst="rect">
@@ -19841,185 +20233,6 @@
       </p:sp>
       <p:sp>
         <p:nvSpPr>
-          <p:cNvPr id="66" name="TextBox 65"/>
-          <p:cNvSpPr txBox="1"/>
-          <p:nvPr/>
-        </p:nvSpPr>
-        <p:spPr>
-          <a:xfrm>
-            <a:off x="365760" y="5422391"/>
-            <a:ext cx="3291840" cy="256032"/>
-          </a:xfrm>
-          <a:prstGeom prst="rect">
-            <a:avLst/>
-          </a:prstGeom>
-          <a:noFill/>
-        </p:spPr>
-        <p:txBody>
-          <a:bodyPr wrap="square">
-            <a:spAutoFit/>
-          </a:bodyPr>
-          <a:lstStyle/>
-          <a:p>
-            <a:pPr algn="l"/>
-            <a:r>
-              <a:rPr sz="1100" b="0" i="0">
-                <a:solidFill>
-                  <a:srgbClr val="444444"/>
-                </a:solidFill>
-              </a:rPr>
-              <a:t>Dallas optics</a:t>
-            </a:r>
-          </a:p>
-        </p:txBody>
-      </p:sp>
-      <p:sp>
-        <p:nvSpPr>
-          <p:cNvPr id="67" name="TextBox 66"/>
-          <p:cNvSpPr txBox="1"/>
-          <p:nvPr/>
-        </p:nvSpPr>
-        <p:spPr>
-          <a:xfrm>
-            <a:off x="3794759" y="5422391"/>
-            <a:ext cx="1280160" cy="256032"/>
-          </a:xfrm>
-          <a:prstGeom prst="rect">
-            <a:avLst/>
-          </a:prstGeom>
-          <a:noFill/>
-        </p:spPr>
-        <p:txBody>
-          <a:bodyPr wrap="square">
-            <a:spAutoFit/>
-          </a:bodyPr>
-          <a:lstStyle/>
-          <a:p>
-            <a:pPr algn="l"/>
-            <a:r>
-              <a:rPr sz="1200" b="1" i="0">
-                <a:solidFill>
-                  <a:srgbClr val="2E7D32"/>
-                </a:solidFill>
-              </a:rPr>
-              <a:t>0</a:t>
-            </a:r>
-          </a:p>
-        </p:txBody>
-      </p:sp>
-      <p:sp>
-        <p:nvSpPr>
-          <p:cNvPr id="68" name="TextBox 67"/>
-          <p:cNvSpPr txBox="1"/>
-          <p:nvPr/>
-        </p:nvSpPr>
-        <p:spPr>
-          <a:xfrm>
-            <a:off x="5257800" y="5422391"/>
-            <a:ext cx="1600200" cy="256032"/>
-          </a:xfrm>
-          <a:prstGeom prst="rect">
-            <a:avLst/>
-          </a:prstGeom>
-          <a:noFill/>
-        </p:spPr>
-        <p:txBody>
-          <a:bodyPr wrap="square">
-            <a:spAutoFit/>
-          </a:bodyPr>
-          <a:lstStyle/>
-          <a:p>
-            <a:pPr algn="l"/>
-            <a:r>
-              <a:rPr sz="1000" b="1" i="0">
-                <a:solidFill>
-                  <a:srgbClr val="2E7D32"/>
-                </a:solidFill>
-              </a:rPr>
-              <a:t>Cleared</a:t>
-            </a:r>
-          </a:p>
-        </p:txBody>
-      </p:sp>
-      <p:sp>
-        <p:nvSpPr>
-          <p:cNvPr id="69" name="TextBox 68"/>
-          <p:cNvSpPr txBox="1"/>
-          <p:nvPr/>
-        </p:nvSpPr>
-        <p:spPr>
-          <a:xfrm>
-            <a:off x="6995159" y="5422391"/>
-            <a:ext cx="4937760" cy="256032"/>
-          </a:xfrm>
-          <a:prstGeom prst="rect">
-            <a:avLst/>
-          </a:prstGeom>
-          <a:noFill/>
-        </p:spPr>
-        <p:txBody>
-          <a:bodyPr wrap="square">
-            <a:spAutoFit/>
-          </a:bodyPr>
-          <a:lstStyle/>
-          <a:p>
-            <a:pPr algn="l"/>
-            <a:r>
-              <a:rPr sz="1000" b="0" i="0">
-                <a:solidFill>
-                  <a:srgbClr val="444444"/>
-                </a:solidFill>
-              </a:rPr>
-              <a:t>No suspicious patterns found</a:t>
-            </a:r>
-          </a:p>
-        </p:txBody>
-      </p:sp>
-      <p:sp>
-        <p:nvSpPr>
-          <p:cNvPr id="70" name="Rectangle 69"/>
-          <p:cNvSpPr/>
-          <p:nvPr/>
-        </p:nvSpPr>
-        <p:spPr>
-          <a:xfrm>
-            <a:off x="274320" y="5733287"/>
-            <a:ext cx="11640312" cy="356616"/>
-          </a:xfrm>
-          <a:prstGeom prst="rect">
-            <a:avLst/>
-          </a:prstGeom>
-          <a:solidFill>
-            <a:srgbClr val="F0F9F2"/>
-          </a:solidFill>
-          <a:ln>
-            <a:noFill/>
-          </a:ln>
-        </p:spPr>
-        <p:style>
-          <a:lnRef idx="1">
-            <a:schemeClr val="accent1"/>
-          </a:lnRef>
-          <a:fillRef idx="3">
-            <a:schemeClr val="accent1"/>
-          </a:fillRef>
-          <a:effectRef idx="2">
-            <a:schemeClr val="accent1"/>
-          </a:effectRef>
-          <a:fontRef idx="minor">
-            <a:schemeClr val="lt1"/>
-          </a:fontRef>
-        </p:style>
-        <p:txBody>
-          <a:bodyPr rtlCol="0" anchor="ctr"/>
-          <a:lstStyle/>
-          <a:p>
-            <a:pPr algn="ctr"/>
-          </a:p>
-        </p:txBody>
-      </p:sp>
-      <p:sp>
-        <p:nvSpPr>
           <p:cNvPr id="71" name="TextBox 70"/>
           <p:cNvSpPr txBox="1"/>
           <p:nvPr/>
@@ -20226,7 +20439,7 @@
                   <a:srgbClr val="FFFFFF"/>
                 </a:solidFill>
               </a:rPr>
-              <a:t>7 providers had payments automatically held  ·  0 flagged for manual review  ·  5 cleared</a:t>
+              <a:t>5 providers had payments automatically held  ·  3 flagged for manual review  ·  4 cleared</a:t>
             </a:r>
           </a:p>
         </p:txBody>
@@ -20905,7 +21118,7 @@
                   <a:srgbClr val="FFFFFF"/>
                 </a:solidFill>
               </a:rPr>
-              <a:t>68/100</a:t>
+              <a:t>54/100</a:t>
             </a:r>
           </a:p>
         </p:txBody>
@@ -21161,7 +21374,7 @@
                   <a:srgbClr val="E07B39"/>
                 </a:solidFill>
               </a:rPr>
-              <a:t>Risk score: 68/100</a:t>
+              <a:t>Risk score: 54/100</a:t>
             </a:r>
           </a:p>
         </p:txBody>
@@ -21360,7 +21573,7 @@
                   <a:srgbClr val="FFFFFF"/>
                 </a:solidFill>
               </a:rPr>
-              <a:t>50/100</a:t>
+              <a:t>40/100</a:t>
             </a:r>
           </a:p>
         </p:txBody>
@@ -21616,7 +21829,7 @@
                   <a:srgbClr val="E07B39"/>
                 </a:solidFill>
               </a:rPr>
-              <a:t>Risk score: 50/100</a:t>
+              <a:t>Risk score: 40/100</a:t>
             </a:r>
           </a:p>
         </p:txBody>
@@ -22295,7 +22508,7 @@
                   <a:srgbClr val="FFFFFF"/>
                 </a:solidFill>
               </a:rPr>
-              <a:t>100/100</a:t>
+              <a:t>96/100</a:t>
             </a:r>
           </a:p>
         </p:txBody>
@@ -22827,7 +23040,7 @@
                   <a:srgbClr val="FFFFFF"/>
                 </a:solidFill>
               </a:rPr>
-              <a:t>100/100</a:t>
+              <a:t>78/100</a:t>
             </a:r>
           </a:p>
         </p:txBody>
@@ -23359,7 +23572,7 @@
                   <a:srgbClr val="FFFFFF"/>
                 </a:solidFill>
               </a:rPr>
-              <a:t>100/100</a:t>
+              <a:t>99/100</a:t>
             </a:r>
           </a:p>
         </p:txBody>
@@ -24405,7 +24618,7 @@
                   <a:srgbClr val="FFFFFF"/>
                 </a:solidFill>
               </a:rPr>
-              <a:t>88/100</a:t>
+              <a:t>74/100</a:t>
             </a:r>
           </a:p>
         </p:txBody>
@@ -25130,7 +25343,7 @@
                   <a:srgbClr val="D62839"/>
                 </a:solidFill>
               </a:rPr>
-              <a:t>Also had co-billing in 55% of months → total score 88</a:t>
+              <a:t>Also had co-billing in 55% of months → total score 74</a:t>
             </a:r>
           </a:p>
         </p:txBody>
@@ -25329,7 +25542,7 @@
                   <a:srgbClr val="FFFFFF"/>
                 </a:solidFill>
               </a:rPr>
-              <a:t>100/100</a:t>
+              <a:t>84/100</a:t>
             </a:r>
           </a:p>
         </p:txBody>

</xml_diff>